<commit_message>
docs: add full frontend page map to README and fix PPT page-map slide
- README: new "Frontend Page Map" section listing all 25 routes verified
  against App.tsx, including Planning Architect, Prompt Library, and
  previously-undocumented pages (Playground, Evaluations, Safety, Usage,
  Control Plane, Voice Agents, Blueprints, Marketplace, What Should I
  Build, My/Published/Shared Projects, API Keys, Team Members, Agent
  Versions, Profile, Settings, Approval Page).
- PPT: added the missing Approval Page entry to the page-map slide,
  corrected the page count from 24 to 25, and fixed the Control Plane
  description to match what that page actually shows.

Co-Authored-By: Claude Sonnet 5 <noreply@anthropic.com>
</commit_message>
<xml_diff>
--- a/docs/AgentForge-PresentationV7.0.pptx
+++ b/docs/AgentForge-PresentationV7.0.pptx
@@ -9247,7 +9247,7 @@
                   <a:srgbClr val="FFFFFF"/>
                 </a:solidFill>
               </a:rPr>
-              <a:t>Frontend Page Map  (24 Pages · React SPA)</a:t>
+              <a:t>Frontend Page Map  (25 Pages · React SPA)</a:t>
             </a:r>
           </a:p>
         </p:txBody>
@@ -9261,7 +9261,7 @@
         <p:spPr>
           <a:xfrm>
             <a:off x="320040" y="960120"/>
-            <a:ext cx="2798064" cy="566928"/>
+            <a:ext cx="2798064" cy="548640"/>
           </a:xfrm>
           <a:prstGeom prst="rect">
             <a:avLst/>
@@ -9303,7 +9303,7 @@
         </p:nvSpPr>
         <p:spPr>
           <a:xfrm>
-            <a:off x="411480" y="996696"/>
+            <a:off x="411480" y="987552"/>
             <a:ext cx="1188720" cy="475488"/>
           </a:xfrm>
           <a:prstGeom prst="rect">
@@ -9319,7 +9319,7 @@
           <a:p>
             <a:pPr algn="l"/>
             <a:r>
-              <a:rPr sz="1100" b="1">
+              <a:rPr sz="1050" b="1">
                 <a:solidFill>
                   <a:srgbClr val="606EF5"/>
                 </a:solidFill>
@@ -9337,7 +9337,7 @@
         </p:nvSpPr>
         <p:spPr>
           <a:xfrm>
-            <a:off x="1600200" y="1024128"/>
+            <a:off x="1600200" y="1014984"/>
             <a:ext cx="1426464" cy="475488"/>
           </a:xfrm>
           <a:prstGeom prst="rect">
@@ -9353,7 +9353,7 @@
           <a:p>
             <a:pPr algn="l"/>
             <a:r>
-              <a:rPr sz="950" b="0">
+              <a:rPr sz="900" b="0">
                 <a:solidFill>
                   <a:srgbClr val="CBD5E1"/>
                 </a:solidFill>
@@ -9372,7 +9372,7 @@
         <p:spPr>
           <a:xfrm>
             <a:off x="3282696" y="960120"/>
-            <a:ext cx="2798064" cy="566928"/>
+            <a:ext cx="2798064" cy="548640"/>
           </a:xfrm>
           <a:prstGeom prst="rect">
             <a:avLst/>
@@ -9414,7 +9414,7 @@
         </p:nvSpPr>
         <p:spPr>
           <a:xfrm>
-            <a:off x="3374136" y="996696"/>
+            <a:off x="3374136" y="987552"/>
             <a:ext cx="1188720" cy="475488"/>
           </a:xfrm>
           <a:prstGeom prst="rect">
@@ -9430,7 +9430,7 @@
           <a:p>
             <a:pPr algn="l"/>
             <a:r>
-              <a:rPr sz="1100" b="1">
+              <a:rPr sz="1050" b="1">
                 <a:solidFill>
                   <a:srgbClr val="606EF5"/>
                 </a:solidFill>
@@ -9448,7 +9448,7 @@
         </p:nvSpPr>
         <p:spPr>
           <a:xfrm>
-            <a:off x="4562856" y="1024128"/>
+            <a:off x="4562856" y="1014984"/>
             <a:ext cx="1426464" cy="475488"/>
           </a:xfrm>
           <a:prstGeom prst="rect">
@@ -9464,7 +9464,7 @@
           <a:p>
             <a:pPr algn="l"/>
             <a:r>
-              <a:rPr sz="950" b="0">
+              <a:rPr sz="900" b="0">
                 <a:solidFill>
                   <a:srgbClr val="CBD5E1"/>
                 </a:solidFill>
@@ -9483,7 +9483,7 @@
         <p:spPr>
           <a:xfrm>
             <a:off x="6245352" y="960120"/>
-            <a:ext cx="2798064" cy="566928"/>
+            <a:ext cx="2798064" cy="548640"/>
           </a:xfrm>
           <a:prstGeom prst="rect">
             <a:avLst/>
@@ -9525,7 +9525,7 @@
         </p:nvSpPr>
         <p:spPr>
           <a:xfrm>
-            <a:off x="6336792" y="996696"/>
+            <a:off x="6336792" y="987552"/>
             <a:ext cx="1188720" cy="475488"/>
           </a:xfrm>
           <a:prstGeom prst="rect">
@@ -9541,7 +9541,7 @@
           <a:p>
             <a:pPr algn="l"/>
             <a:r>
-              <a:rPr sz="1100" b="1">
+              <a:rPr sz="1050" b="1">
                 <a:solidFill>
                   <a:srgbClr val="606EF5"/>
                 </a:solidFill>
@@ -9559,7 +9559,7 @@
         </p:nvSpPr>
         <p:spPr>
           <a:xfrm>
-            <a:off x="7525512" y="1024128"/>
+            <a:off x="7525512" y="1014984"/>
             <a:ext cx="1426464" cy="475488"/>
           </a:xfrm>
           <a:prstGeom prst="rect">
@@ -9575,7 +9575,7 @@
           <a:p>
             <a:pPr algn="l"/>
             <a:r>
-              <a:rPr sz="950" b="0">
+              <a:rPr sz="900" b="0">
                 <a:solidFill>
                   <a:srgbClr val="CBD5E1"/>
                 </a:solidFill>
@@ -9594,7 +9594,7 @@
         <p:spPr>
           <a:xfrm>
             <a:off x="9208008" y="960120"/>
-            <a:ext cx="2798064" cy="566928"/>
+            <a:ext cx="2798064" cy="548640"/>
           </a:xfrm>
           <a:prstGeom prst="rect">
             <a:avLst/>
@@ -9636,7 +9636,7 @@
         </p:nvSpPr>
         <p:spPr>
           <a:xfrm>
-            <a:off x="9299448" y="996696"/>
+            <a:off x="9299448" y="987552"/>
             <a:ext cx="1188720" cy="475488"/>
           </a:xfrm>
           <a:prstGeom prst="rect">
@@ -9652,7 +9652,7 @@
           <a:p>
             <a:pPr algn="l"/>
             <a:r>
-              <a:rPr sz="1100" b="1">
+              <a:rPr sz="1050" b="1">
                 <a:solidFill>
                   <a:srgbClr val="606EF5"/>
                 </a:solidFill>
@@ -9670,7 +9670,7 @@
         </p:nvSpPr>
         <p:spPr>
           <a:xfrm>
-            <a:off x="10488168" y="1024128"/>
+            <a:off x="10488168" y="1014984"/>
             <a:ext cx="1426464" cy="475488"/>
           </a:xfrm>
           <a:prstGeom prst="rect">
@@ -9686,7 +9686,7 @@
           <a:p>
             <a:pPr algn="l"/>
             <a:r>
-              <a:rPr sz="950" b="0">
+              <a:rPr sz="900" b="0">
                 <a:solidFill>
                   <a:srgbClr val="CBD5E1"/>
                 </a:solidFill>
@@ -9704,8 +9704,8 @@
         </p:nvSpPr>
         <p:spPr>
           <a:xfrm>
-            <a:off x="320040" y="1581912"/>
-            <a:ext cx="2798064" cy="566928"/>
+            <a:off x="320040" y="1563624"/>
+            <a:ext cx="2798064" cy="548640"/>
           </a:xfrm>
           <a:prstGeom prst="rect">
             <a:avLst/>
@@ -9747,7 +9747,7 @@
         </p:nvSpPr>
         <p:spPr>
           <a:xfrm>
-            <a:off x="411480" y="1618488"/>
+            <a:off x="411480" y="1591056"/>
             <a:ext cx="1188720" cy="475488"/>
           </a:xfrm>
           <a:prstGeom prst="rect">
@@ -9763,7 +9763,7 @@
           <a:p>
             <a:pPr algn="l"/>
             <a:r>
-              <a:rPr sz="1100" b="1">
+              <a:rPr sz="1050" b="1">
                 <a:solidFill>
                   <a:srgbClr val="606EF5"/>
                 </a:solidFill>
@@ -9781,7 +9781,7 @@
         </p:nvSpPr>
         <p:spPr>
           <a:xfrm>
-            <a:off x="1600200" y="1645920"/>
+            <a:off x="1600200" y="1618488"/>
             <a:ext cx="1426464" cy="475488"/>
           </a:xfrm>
           <a:prstGeom prst="rect">
@@ -9797,7 +9797,7 @@
           <a:p>
             <a:pPr algn="l"/>
             <a:r>
-              <a:rPr sz="950" b="0">
+              <a:rPr sz="900" b="0">
                 <a:solidFill>
                   <a:srgbClr val="CBD5E1"/>
                 </a:solidFill>
@@ -9815,8 +9815,8 @@
         </p:nvSpPr>
         <p:spPr>
           <a:xfrm>
-            <a:off x="3282696" y="1581912"/>
-            <a:ext cx="2798064" cy="566928"/>
+            <a:off x="3282696" y="1563624"/>
+            <a:ext cx="2798064" cy="548640"/>
           </a:xfrm>
           <a:prstGeom prst="rect">
             <a:avLst/>
@@ -9858,7 +9858,7 @@
         </p:nvSpPr>
         <p:spPr>
           <a:xfrm>
-            <a:off x="3374136" y="1618488"/>
+            <a:off x="3374136" y="1591056"/>
             <a:ext cx="1188720" cy="475488"/>
           </a:xfrm>
           <a:prstGeom prst="rect">
@@ -9874,7 +9874,7 @@
           <a:p>
             <a:pPr algn="l"/>
             <a:r>
-              <a:rPr sz="1100" b="1">
+              <a:rPr sz="1050" b="1">
                 <a:solidFill>
                   <a:srgbClr val="606EF5"/>
                 </a:solidFill>
@@ -9892,7 +9892,7 @@
         </p:nvSpPr>
         <p:spPr>
           <a:xfrm>
-            <a:off x="4562856" y="1645920"/>
+            <a:off x="4562856" y="1618488"/>
             <a:ext cx="1426464" cy="475488"/>
           </a:xfrm>
           <a:prstGeom prst="rect">
@@ -9908,7 +9908,7 @@
           <a:p>
             <a:pPr algn="l"/>
             <a:r>
-              <a:rPr sz="950" b="0">
+              <a:rPr sz="900" b="0">
                 <a:solidFill>
                   <a:srgbClr val="CBD5E1"/>
                 </a:solidFill>
@@ -9926,8 +9926,8 @@
         </p:nvSpPr>
         <p:spPr>
           <a:xfrm>
-            <a:off x="6245352" y="1581912"/>
-            <a:ext cx="2798064" cy="566928"/>
+            <a:off x="6245352" y="1563624"/>
+            <a:ext cx="2798064" cy="548640"/>
           </a:xfrm>
           <a:prstGeom prst="rect">
             <a:avLst/>
@@ -9969,7 +9969,7 @@
         </p:nvSpPr>
         <p:spPr>
           <a:xfrm>
-            <a:off x="6336792" y="1618488"/>
+            <a:off x="6336792" y="1591056"/>
             <a:ext cx="1188720" cy="475488"/>
           </a:xfrm>
           <a:prstGeom prst="rect">
@@ -9985,7 +9985,7 @@
           <a:p>
             <a:pPr algn="l"/>
             <a:r>
-              <a:rPr sz="1100" b="1">
+              <a:rPr sz="1050" b="1">
                 <a:solidFill>
                   <a:srgbClr val="606EF5"/>
                 </a:solidFill>
@@ -10003,7 +10003,7 @@
         </p:nvSpPr>
         <p:spPr>
           <a:xfrm>
-            <a:off x="7525512" y="1645920"/>
+            <a:off x="7525512" y="1618488"/>
             <a:ext cx="1426464" cy="475488"/>
           </a:xfrm>
           <a:prstGeom prst="rect">
@@ -10019,7 +10019,7 @@
           <a:p>
             <a:pPr algn="l"/>
             <a:r>
-              <a:rPr sz="950" b="0">
+              <a:rPr sz="900" b="0">
                 <a:solidFill>
                   <a:srgbClr val="CBD5E1"/>
                 </a:solidFill>
@@ -10037,8 +10037,8 @@
         </p:nvSpPr>
         <p:spPr>
           <a:xfrm>
-            <a:off x="9208008" y="1581912"/>
-            <a:ext cx="2798064" cy="566928"/>
+            <a:off x="9208008" y="1563624"/>
+            <a:ext cx="2798064" cy="548640"/>
           </a:xfrm>
           <a:prstGeom prst="rect">
             <a:avLst/>
@@ -10080,7 +10080,7 @@
         </p:nvSpPr>
         <p:spPr>
           <a:xfrm>
-            <a:off x="9299448" y="1618488"/>
+            <a:off x="9299448" y="1591056"/>
             <a:ext cx="1188720" cy="475488"/>
           </a:xfrm>
           <a:prstGeom prst="rect">
@@ -10096,7 +10096,7 @@
           <a:p>
             <a:pPr algn="l"/>
             <a:r>
-              <a:rPr sz="1100" b="1">
+              <a:rPr sz="1050" b="1">
                 <a:solidFill>
                   <a:srgbClr val="606EF5"/>
                 </a:solidFill>
@@ -10114,7 +10114,7 @@
         </p:nvSpPr>
         <p:spPr>
           <a:xfrm>
-            <a:off x="10488168" y="1645920"/>
+            <a:off x="10488168" y="1618488"/>
             <a:ext cx="1426464" cy="475488"/>
           </a:xfrm>
           <a:prstGeom prst="rect">
@@ -10130,7 +10130,7 @@
           <a:p>
             <a:pPr algn="l"/>
             <a:r>
-              <a:rPr sz="950" b="0">
+              <a:rPr sz="900" b="0">
                 <a:solidFill>
                   <a:srgbClr val="CBD5E1"/>
                 </a:solidFill>
@@ -10148,8 +10148,8 @@
         </p:nvSpPr>
         <p:spPr>
           <a:xfrm>
-            <a:off x="320040" y="2203704"/>
-            <a:ext cx="2798064" cy="566928"/>
+            <a:off x="320040" y="2167128"/>
+            <a:ext cx="2798064" cy="548640"/>
           </a:xfrm>
           <a:prstGeom prst="rect">
             <a:avLst/>
@@ -10191,7 +10191,7 @@
         </p:nvSpPr>
         <p:spPr>
           <a:xfrm>
-            <a:off x="411480" y="2240280"/>
+            <a:off x="411480" y="2194560"/>
             <a:ext cx="1188720" cy="475488"/>
           </a:xfrm>
           <a:prstGeom prst="rect">
@@ -10207,7 +10207,7 @@
           <a:p>
             <a:pPr algn="l"/>
             <a:r>
-              <a:rPr sz="1100" b="1">
+              <a:rPr sz="1050" b="1">
                 <a:solidFill>
                   <a:srgbClr val="606EF5"/>
                 </a:solidFill>
@@ -10225,7 +10225,7 @@
         </p:nvSpPr>
         <p:spPr>
           <a:xfrm>
-            <a:off x="1600200" y="2267712"/>
+            <a:off x="1600200" y="2221992"/>
             <a:ext cx="1426464" cy="475488"/>
           </a:xfrm>
           <a:prstGeom prst="rect">
@@ -10241,7 +10241,7 @@
           <a:p>
             <a:pPr algn="l"/>
             <a:r>
-              <a:rPr sz="950" b="0">
+              <a:rPr sz="900" b="0">
                 <a:solidFill>
                   <a:srgbClr val="CBD5E1"/>
                 </a:solidFill>
@@ -10259,8 +10259,8 @@
         </p:nvSpPr>
         <p:spPr>
           <a:xfrm>
-            <a:off x="3282696" y="2203704"/>
-            <a:ext cx="2798064" cy="566928"/>
+            <a:off x="3282696" y="2167128"/>
+            <a:ext cx="2798064" cy="548640"/>
           </a:xfrm>
           <a:prstGeom prst="rect">
             <a:avLst/>
@@ -10302,7 +10302,7 @@
         </p:nvSpPr>
         <p:spPr>
           <a:xfrm>
-            <a:off x="3374136" y="2240280"/>
+            <a:off x="3374136" y="2194560"/>
             <a:ext cx="1188720" cy="475488"/>
           </a:xfrm>
           <a:prstGeom prst="rect">
@@ -10318,7 +10318,7 @@
           <a:p>
             <a:pPr algn="l"/>
             <a:r>
-              <a:rPr sz="1100" b="1">
+              <a:rPr sz="1050" b="1">
                 <a:solidFill>
                   <a:srgbClr val="606EF5"/>
                 </a:solidFill>
@@ -10336,7 +10336,7 @@
         </p:nvSpPr>
         <p:spPr>
           <a:xfrm>
-            <a:off x="4562856" y="2267712"/>
+            <a:off x="4562856" y="2221992"/>
             <a:ext cx="1426464" cy="475488"/>
           </a:xfrm>
           <a:prstGeom prst="rect">
@@ -10352,12 +10352,12 @@
           <a:p>
             <a:pPr algn="l"/>
             <a:r>
-              <a:rPr sz="950" b="0">
+              <a:rPr sz="900" b="0">
                 <a:solidFill>
                   <a:srgbClr val="CBD5E1"/>
                 </a:solidFill>
               </a:rPr>
-              <a:t>Live workflow status, modify/pause/resume running agents</a:t>
+              <a:t>Live platform stats — agents, runs, guardrail triggers, avg latency</a:t>
             </a:r>
           </a:p>
         </p:txBody>
@@ -10370,8 +10370,8 @@
         </p:nvSpPr>
         <p:spPr>
           <a:xfrm>
-            <a:off x="6245352" y="2203704"/>
-            <a:ext cx="2798064" cy="566928"/>
+            <a:off x="6245352" y="2167128"/>
+            <a:ext cx="2798064" cy="548640"/>
           </a:xfrm>
           <a:prstGeom prst="rect">
             <a:avLst/>
@@ -10413,7 +10413,7 @@
         </p:nvSpPr>
         <p:spPr>
           <a:xfrm>
-            <a:off x="6336792" y="2240280"/>
+            <a:off x="6336792" y="2194560"/>
             <a:ext cx="1188720" cy="475488"/>
           </a:xfrm>
           <a:prstGeom prst="rect">
@@ -10429,7 +10429,7 @@
           <a:p>
             <a:pPr algn="l"/>
             <a:r>
-              <a:rPr sz="1100" b="1">
+              <a:rPr sz="1050" b="1">
                 <a:solidFill>
                   <a:srgbClr val="606EF5"/>
                 </a:solidFill>
@@ -10447,7 +10447,7 @@
         </p:nvSpPr>
         <p:spPr>
           <a:xfrm>
-            <a:off x="7525512" y="2267712"/>
+            <a:off x="7525512" y="2221992"/>
             <a:ext cx="1426464" cy="475488"/>
           </a:xfrm>
           <a:prstGeom prst="rect">
@@ -10463,12 +10463,12 @@
           <a:p>
             <a:pPr algn="l"/>
             <a:r>
-              <a:rPr sz="950" b="0">
+              <a:rPr sz="900" b="0">
                 <a:solidFill>
                   <a:srgbClr val="CBD5E1"/>
                 </a:solidFill>
               </a:rPr>
-              <a:t>Per-run execution trace, node-level latency breakdown</a:t>
+              <a:t>Per-run execution trace, "Awaiting Approval" tracking, Review link</a:t>
             </a:r>
           </a:p>
         </p:txBody>
@@ -10481,8 +10481,8 @@
         </p:nvSpPr>
         <p:spPr>
           <a:xfrm>
-            <a:off x="9208008" y="2203704"/>
-            <a:ext cx="2798064" cy="566928"/>
+            <a:off x="9208008" y="2167128"/>
+            <a:ext cx="2798064" cy="548640"/>
           </a:xfrm>
           <a:prstGeom prst="rect">
             <a:avLst/>
@@ -10524,7 +10524,7 @@
         </p:nvSpPr>
         <p:spPr>
           <a:xfrm>
-            <a:off x="9299448" y="2240280"/>
+            <a:off x="9299448" y="2194560"/>
             <a:ext cx="1188720" cy="475488"/>
           </a:xfrm>
           <a:prstGeom prst="rect">
@@ -10540,12 +10540,12 @@
           <a:p>
             <a:pPr algn="l"/>
             <a:r>
-              <a:rPr sz="1100" b="1">
+              <a:rPr sz="1050" b="1">
                 <a:solidFill>
                   <a:srgbClr val="606EF5"/>
                 </a:solidFill>
               </a:rPr>
-              <a:t>🗣️ Voice Agents</a:t>
+              <a:t>✅ Approval Page</a:t>
             </a:r>
           </a:p>
         </p:txBody>
@@ -10558,7 +10558,7 @@
         </p:nvSpPr>
         <p:spPr>
           <a:xfrm>
-            <a:off x="10488168" y="2267712"/>
+            <a:off x="10488168" y="2221992"/>
             <a:ext cx="1426464" cy="475488"/>
           </a:xfrm>
           <a:prstGeom prst="rect">
@@ -10574,12 +10574,12 @@
           <a:p>
             <a:pPr algn="l"/>
             <a:r>
-              <a:rPr sz="950" b="0">
+              <a:rPr sz="900" b="0">
                 <a:solidFill>
                   <a:srgbClr val="CBD5E1"/>
                 </a:solidFill>
               </a:rPr>
-              <a:t>Voice session management, STT/TTS config, audio test</a:t>
+              <a:t>Review a paused run's context, Approve/Reject to resume</a:t>
             </a:r>
           </a:p>
         </p:txBody>
@@ -10592,8 +10592,8 @@
         </p:nvSpPr>
         <p:spPr>
           <a:xfrm>
-            <a:off x="320040" y="2825496"/>
-            <a:ext cx="2798064" cy="566928"/>
+            <a:off x="320040" y="2770632"/>
+            <a:ext cx="2798064" cy="548640"/>
           </a:xfrm>
           <a:prstGeom prst="rect">
             <a:avLst/>
@@ -10635,7 +10635,7 @@
         </p:nvSpPr>
         <p:spPr>
           <a:xfrm>
-            <a:off x="411480" y="2862072"/>
+            <a:off x="411480" y="2798064"/>
             <a:ext cx="1188720" cy="475488"/>
           </a:xfrm>
           <a:prstGeom prst="rect">
@@ -10651,12 +10651,12 @@
           <a:p>
             <a:pPr algn="l"/>
             <a:r>
-              <a:rPr sz="1100" b="1">
+              <a:rPr sz="1050" b="1">
                 <a:solidFill>
                   <a:srgbClr val="606EF5"/>
                 </a:solidFill>
               </a:rPr>
-              <a:t>🗂️ Blueprints</a:t>
+              <a:t>🗣️ Voice Agents</a:t>
             </a:r>
           </a:p>
         </p:txBody>
@@ -10669,7 +10669,7 @@
         </p:nvSpPr>
         <p:spPr>
           <a:xfrm>
-            <a:off x="1600200" y="2889504"/>
+            <a:off x="1600200" y="2825496"/>
             <a:ext cx="1426464" cy="475488"/>
           </a:xfrm>
           <a:prstGeom prst="rect">
@@ -10685,12 +10685,12 @@
           <a:p>
             <a:pPr algn="l"/>
             <a:r>
-              <a:rPr sz="950" b="0">
+              <a:rPr sz="900" b="0">
                 <a:solidFill>
                   <a:srgbClr val="CBD5E1"/>
                 </a:solidFill>
               </a:rPr>
-              <a:t>Reusable agent blueprints library, clone to project</a:t>
+              <a:t>Voice session management, STT/TTS config, audio test</a:t>
             </a:r>
           </a:p>
         </p:txBody>
@@ -10703,8 +10703,8 @@
         </p:nvSpPr>
         <p:spPr>
           <a:xfrm>
-            <a:off x="3282696" y="2825496"/>
-            <a:ext cx="2798064" cy="566928"/>
+            <a:off x="3282696" y="2770632"/>
+            <a:ext cx="2798064" cy="548640"/>
           </a:xfrm>
           <a:prstGeom prst="rect">
             <a:avLst/>
@@ -10746,7 +10746,7 @@
         </p:nvSpPr>
         <p:spPr>
           <a:xfrm>
-            <a:off x="3374136" y="2862072"/>
+            <a:off x="3374136" y="2798064"/>
             <a:ext cx="1188720" cy="475488"/>
           </a:xfrm>
           <a:prstGeom prst="rect">
@@ -10762,12 +10762,12 @@
           <a:p>
             <a:pPr algn="l"/>
             <a:r>
-              <a:rPr sz="1100" b="1">
+              <a:rPr sz="1050" b="1">
                 <a:solidFill>
                   <a:srgbClr val="606EF5"/>
                 </a:solidFill>
               </a:rPr>
-              <a:t>📝 Prompt Library</a:t>
+              <a:t>🗂️ Blueprints</a:t>
             </a:r>
           </a:p>
         </p:txBody>
@@ -10780,7 +10780,7 @@
         </p:nvSpPr>
         <p:spPr>
           <a:xfrm>
-            <a:off x="4562856" y="2889504"/>
+            <a:off x="4562856" y="2825496"/>
             <a:ext cx="1426464" cy="475488"/>
           </a:xfrm>
           <a:prstGeom prst="rect">
@@ -10796,12 +10796,12 @@
           <a:p>
             <a:pPr algn="l"/>
             <a:r>
-              <a:rPr sz="950" b="0">
+              <a:rPr sz="900" b="0">
                 <a:solidFill>
                   <a:srgbClr val="CBD5E1"/>
                 </a:solidFill>
               </a:rPr>
-              <a:t>Curated prompts, search, copy-to-agent</a:t>
+              <a:t>Reusable agent blueprints library, clone to project</a:t>
             </a:r>
           </a:p>
         </p:txBody>
@@ -10814,8 +10814,8 @@
         </p:nvSpPr>
         <p:spPr>
           <a:xfrm>
-            <a:off x="6245352" y="2825496"/>
-            <a:ext cx="2798064" cy="566928"/>
+            <a:off x="6245352" y="2770632"/>
+            <a:ext cx="2798064" cy="548640"/>
           </a:xfrm>
           <a:prstGeom prst="rect">
             <a:avLst/>
@@ -10857,7 +10857,7 @@
         </p:nvSpPr>
         <p:spPr>
           <a:xfrm>
-            <a:off x="6336792" y="2862072"/>
+            <a:off x="6336792" y="2798064"/>
             <a:ext cx="1188720" cy="475488"/>
           </a:xfrm>
           <a:prstGeom prst="rect">
@@ -10873,12 +10873,12 @@
           <a:p>
             <a:pPr algn="l"/>
             <a:r>
-              <a:rPr sz="1100" b="1">
+              <a:rPr sz="1050" b="1">
                 <a:solidFill>
                   <a:srgbClr val="606EF5"/>
                 </a:solidFill>
               </a:rPr>
-              <a:t>💡 What Should I Build</a:t>
+              <a:t>📝 Prompt Library</a:t>
             </a:r>
           </a:p>
         </p:txBody>
@@ -10891,7 +10891,7 @@
         </p:nvSpPr>
         <p:spPr>
           <a:xfrm>
-            <a:off x="7525512" y="2889504"/>
+            <a:off x="7525512" y="2825496"/>
             <a:ext cx="1426464" cy="475488"/>
           </a:xfrm>
           <a:prstGeom prst="rect">
@@ -10907,12 +10907,12 @@
           <a:p>
             <a:pPr algn="l"/>
             <a:r>
-              <a:rPr sz="950" b="0">
+              <a:rPr sz="900" b="0">
                 <a:solidFill>
                   <a:srgbClr val="CBD5E1"/>
                 </a:solidFill>
               </a:rPr>
-              <a:t>AI-guided project ideation based on use-case description</a:t>
+              <a:t>Curated prompts across 10 domains, search, copy-to-agent</a:t>
             </a:r>
           </a:p>
         </p:txBody>
@@ -10925,8 +10925,8 @@
         </p:nvSpPr>
         <p:spPr>
           <a:xfrm>
-            <a:off x="9208008" y="2825496"/>
-            <a:ext cx="2798064" cy="566928"/>
+            <a:off x="9208008" y="2770632"/>
+            <a:ext cx="2798064" cy="548640"/>
           </a:xfrm>
           <a:prstGeom prst="rect">
             <a:avLst/>
@@ -10968,7 +10968,7 @@
         </p:nvSpPr>
         <p:spPr>
           <a:xfrm>
-            <a:off x="9299448" y="2862072"/>
+            <a:off x="9299448" y="2798064"/>
             <a:ext cx="1188720" cy="475488"/>
           </a:xfrm>
           <a:prstGeom prst="rect">
@@ -10984,12 +10984,12 @@
           <a:p>
             <a:pPr algn="l"/>
             <a:r>
-              <a:rPr sz="1100" b="1">
+              <a:rPr sz="1050" b="1">
                 <a:solidFill>
                   <a:srgbClr val="606EF5"/>
                 </a:solidFill>
               </a:rPr>
-              <a:t>🗺️ My Projects</a:t>
+              <a:t>💡 What Should I Build</a:t>
             </a:r>
           </a:p>
         </p:txBody>
@@ -11002,7 +11002,7 @@
         </p:nvSpPr>
         <p:spPr>
           <a:xfrm>
-            <a:off x="10488168" y="2889504"/>
+            <a:off x="10488168" y="2825496"/>
             <a:ext cx="1426464" cy="475488"/>
           </a:xfrm>
           <a:prstGeom prst="rect">
@@ -11018,12 +11018,12 @@
           <a:p>
             <a:pPr algn="l"/>
             <a:r>
-              <a:rPr sz="950" b="0">
+              <a:rPr sz="900" b="0">
                 <a:solidFill>
                   <a:srgbClr val="CBD5E1"/>
                 </a:solidFill>
               </a:rPr>
-              <a:t>Project cards, download ZIP, open in Architect</a:t>
+              <a:t>AI-guided project ideation based on use-case description</a:t>
             </a:r>
           </a:p>
         </p:txBody>
@@ -11036,8 +11036,8 @@
         </p:nvSpPr>
         <p:spPr>
           <a:xfrm>
-            <a:off x="320040" y="3447288"/>
-            <a:ext cx="2798064" cy="566928"/>
+            <a:off x="320040" y="3374136"/>
+            <a:ext cx="2798064" cy="548640"/>
           </a:xfrm>
           <a:prstGeom prst="rect">
             <a:avLst/>
@@ -11079,7 +11079,7 @@
         </p:nvSpPr>
         <p:spPr>
           <a:xfrm>
-            <a:off x="411480" y="3483864"/>
+            <a:off x="411480" y="3401568"/>
             <a:ext cx="1188720" cy="475488"/>
           </a:xfrm>
           <a:prstGeom prst="rect">
@@ -11095,12 +11095,12 @@
           <a:p>
             <a:pPr algn="l"/>
             <a:r>
-              <a:rPr sz="1100" b="1">
+              <a:rPr sz="1050" b="1">
                 <a:solidFill>
                   <a:srgbClr val="606EF5"/>
                 </a:solidFill>
               </a:rPr>
-              <a:t>🌍 Published Projects</a:t>
+              <a:t>🗺️ My Projects</a:t>
             </a:r>
           </a:p>
         </p:txBody>
@@ -11113,7 +11113,7 @@
         </p:nvSpPr>
         <p:spPr>
           <a:xfrm>
-            <a:off x="1600200" y="3511296"/>
+            <a:off x="1600200" y="3429000"/>
             <a:ext cx="1426464" cy="475488"/>
           </a:xfrm>
           <a:prstGeom prst="rect">
@@ -11129,12 +11129,12 @@
           <a:p>
             <a:pPr algn="l"/>
             <a:r>
-              <a:rPr sz="950" b="0">
+              <a:rPr sz="900" b="0">
                 <a:solidFill>
                   <a:srgbClr val="CBD5E1"/>
                 </a:solidFill>
               </a:rPr>
-              <a:t>Published agents visible to org members</a:t>
+              <a:t>Project cards, download ZIP, open in Architect</a:t>
             </a:r>
           </a:p>
         </p:txBody>
@@ -11147,8 +11147,8 @@
         </p:nvSpPr>
         <p:spPr>
           <a:xfrm>
-            <a:off x="3282696" y="3447288"/>
-            <a:ext cx="2798064" cy="566928"/>
+            <a:off x="3282696" y="3374136"/>
+            <a:ext cx="2798064" cy="548640"/>
           </a:xfrm>
           <a:prstGeom prst="rect">
             <a:avLst/>
@@ -11190,7 +11190,7 @@
         </p:nvSpPr>
         <p:spPr>
           <a:xfrm>
-            <a:off x="3374136" y="3483864"/>
+            <a:off x="3374136" y="3401568"/>
             <a:ext cx="1188720" cy="475488"/>
           </a:xfrm>
           <a:prstGeom prst="rect">
@@ -11206,12 +11206,12 @@
           <a:p>
             <a:pPr algn="l"/>
             <a:r>
-              <a:rPr sz="1100" b="1">
+              <a:rPr sz="1050" b="1">
                 <a:solidFill>
                   <a:srgbClr val="606EF5"/>
                 </a:solidFill>
               </a:rPr>
-              <a:t>🤝 Shared Projects</a:t>
+              <a:t>🌍 Published Projects</a:t>
             </a:r>
           </a:p>
         </p:txBody>
@@ -11224,7 +11224,7 @@
         </p:nvSpPr>
         <p:spPr>
           <a:xfrm>
-            <a:off x="4562856" y="3511296"/>
+            <a:off x="4562856" y="3429000"/>
             <a:ext cx="1426464" cy="475488"/>
           </a:xfrm>
           <a:prstGeom prst="rect">
@@ -11240,12 +11240,12 @@
           <a:p>
             <a:pPr algn="l"/>
             <a:r>
-              <a:rPr sz="950" b="0">
+              <a:rPr sz="900" b="0">
                 <a:solidFill>
                   <a:srgbClr val="CBD5E1"/>
                 </a:solidFill>
               </a:rPr>
-              <a:t>Projects shared with you across the org</a:t>
+              <a:t>Published agents visible to org members</a:t>
             </a:r>
           </a:p>
         </p:txBody>
@@ -11258,8 +11258,8 @@
         </p:nvSpPr>
         <p:spPr>
           <a:xfrm>
-            <a:off x="6245352" y="3447288"/>
-            <a:ext cx="2798064" cy="566928"/>
+            <a:off x="6245352" y="3374136"/>
+            <a:ext cx="2798064" cy="548640"/>
           </a:xfrm>
           <a:prstGeom prst="rect">
             <a:avLst/>
@@ -11301,7 +11301,7 @@
         </p:nvSpPr>
         <p:spPr>
           <a:xfrm>
-            <a:off x="6336792" y="3483864"/>
+            <a:off x="6336792" y="3401568"/>
             <a:ext cx="1188720" cy="475488"/>
           </a:xfrm>
           <a:prstGeom prst="rect">
@@ -11317,12 +11317,12 @@
           <a:p>
             <a:pPr algn="l"/>
             <a:r>
-              <a:rPr sz="1100" b="1">
+              <a:rPr sz="1050" b="1">
                 <a:solidFill>
                   <a:srgbClr val="606EF5"/>
                 </a:solidFill>
               </a:rPr>
-              <a:t>🛒 Marketplace</a:t>
+              <a:t>🤝 Shared Projects</a:t>
             </a:r>
           </a:p>
         </p:txBody>
@@ -11335,7 +11335,7 @@
         </p:nvSpPr>
         <p:spPr>
           <a:xfrm>
-            <a:off x="7525512" y="3511296"/>
+            <a:off x="7525512" y="3429000"/>
             <a:ext cx="1426464" cy="475488"/>
           </a:xfrm>
           <a:prstGeom prst="rect">
@@ -11351,12 +11351,12 @@
           <a:p>
             <a:pPr algn="l"/>
             <a:r>
-              <a:rPr sz="950" b="0">
+              <a:rPr sz="900" b="0">
                 <a:solidFill>
                   <a:srgbClr val="CBD5E1"/>
                 </a:solidFill>
               </a:rPr>
-              <a:t>Community agent templates — import &amp; customise</a:t>
+              <a:t>Projects shared with you across the org</a:t>
             </a:r>
           </a:p>
         </p:txBody>
@@ -11369,8 +11369,8 @@
         </p:nvSpPr>
         <p:spPr>
           <a:xfrm>
-            <a:off x="9208008" y="3447288"/>
-            <a:ext cx="2798064" cy="566928"/>
+            <a:off x="9208008" y="3374136"/>
+            <a:ext cx="2798064" cy="548640"/>
           </a:xfrm>
           <a:prstGeom prst="rect">
             <a:avLst/>
@@ -11412,7 +11412,7 @@
         </p:nvSpPr>
         <p:spPr>
           <a:xfrm>
-            <a:off x="9299448" y="3483864"/>
+            <a:off x="9299448" y="3401568"/>
             <a:ext cx="1188720" cy="475488"/>
           </a:xfrm>
           <a:prstGeom prst="rect">
@@ -11428,12 +11428,12 @@
           <a:p>
             <a:pPr algn="l"/>
             <a:r>
-              <a:rPr sz="1100" b="1">
+              <a:rPr sz="1050" b="1">
                 <a:solidFill>
                   <a:srgbClr val="606EF5"/>
                 </a:solidFill>
               </a:rPr>
-              <a:t>🔑 API Keys</a:t>
+              <a:t>🛒 Marketplace</a:t>
             </a:r>
           </a:p>
         </p:txBody>
@@ -11446,7 +11446,7 @@
         </p:nvSpPr>
         <p:spPr>
           <a:xfrm>
-            <a:off x="10488168" y="3511296"/>
+            <a:off x="10488168" y="3429000"/>
             <a:ext cx="1426464" cy="475488"/>
           </a:xfrm>
           <a:prstGeom prst="rect">
@@ -11462,12 +11462,12 @@
           <a:p>
             <a:pPr algn="l"/>
             <a:r>
-              <a:rPr sz="950" b="0">
+              <a:rPr sz="900" b="0">
                 <a:solidFill>
                   <a:srgbClr val="CBD5E1"/>
                 </a:solidFill>
               </a:rPr>
-              <a:t>Generate, list, revoke programmatic keys</a:t>
+              <a:t>Community agent templates — import &amp; customise</a:t>
             </a:r>
           </a:p>
         </p:txBody>
@@ -11480,8 +11480,8 @@
         </p:nvSpPr>
         <p:spPr>
           <a:xfrm>
-            <a:off x="320040" y="4069080"/>
-            <a:ext cx="2798064" cy="566928"/>
+            <a:off x="320040" y="3977640"/>
+            <a:ext cx="2798064" cy="548640"/>
           </a:xfrm>
           <a:prstGeom prst="rect">
             <a:avLst/>
@@ -11523,7 +11523,7 @@
         </p:nvSpPr>
         <p:spPr>
           <a:xfrm>
-            <a:off x="411480" y="4105656"/>
+            <a:off x="411480" y="4005072"/>
             <a:ext cx="1188720" cy="475488"/>
           </a:xfrm>
           <a:prstGeom prst="rect">
@@ -11539,12 +11539,12 @@
           <a:p>
             <a:pPr algn="l"/>
             <a:r>
-              <a:rPr sz="1100" b="1">
+              <a:rPr sz="1050" b="1">
                 <a:solidFill>
                   <a:srgbClr val="606EF5"/>
                 </a:solidFill>
               </a:rPr>
-              <a:t>👥 Team Members</a:t>
+              <a:t>🔑 API Keys</a:t>
             </a:r>
           </a:p>
         </p:txBody>
@@ -11557,7 +11557,7 @@
         </p:nvSpPr>
         <p:spPr>
           <a:xfrm>
-            <a:off x="1600200" y="4133088"/>
+            <a:off x="1600200" y="4032504"/>
             <a:ext cx="1426464" cy="475488"/>
           </a:xfrm>
           <a:prstGeom prst="rect">
@@ -11573,12 +11573,12 @@
           <a:p>
             <a:pPr algn="l"/>
             <a:r>
-              <a:rPr sz="950" b="0">
+              <a:rPr sz="900" b="0">
                 <a:solidFill>
                   <a:srgbClr val="CBD5E1"/>
                 </a:solidFill>
               </a:rPr>
-              <a:t>Invite, assign roles, deactivate users</a:t>
+              <a:t>Generate, list, revoke programmatic keys</a:t>
             </a:r>
           </a:p>
         </p:txBody>
@@ -11591,8 +11591,8 @@
         </p:nvSpPr>
         <p:spPr>
           <a:xfrm>
-            <a:off x="3282696" y="4069080"/>
-            <a:ext cx="2798064" cy="566928"/>
+            <a:off x="3282696" y="3977640"/>
+            <a:ext cx="2798064" cy="548640"/>
           </a:xfrm>
           <a:prstGeom prst="rect">
             <a:avLst/>
@@ -11634,7 +11634,7 @@
         </p:nvSpPr>
         <p:spPr>
           <a:xfrm>
-            <a:off x="3374136" y="4105656"/>
+            <a:off x="3374136" y="4005072"/>
             <a:ext cx="1188720" cy="475488"/>
           </a:xfrm>
           <a:prstGeom prst="rect">
@@ -11650,12 +11650,12 @@
           <a:p>
             <a:pPr algn="l"/>
             <a:r>
-              <a:rPr sz="1100" b="1">
+              <a:rPr sz="1050" b="1">
                 <a:solidFill>
                   <a:srgbClr val="606EF5"/>
                 </a:solidFill>
               </a:rPr>
-              <a:t>📅 Agent Versions</a:t>
+              <a:t>👥 Team Members</a:t>
             </a:r>
           </a:p>
         </p:txBody>
@@ -11668,7 +11668,7 @@
         </p:nvSpPr>
         <p:spPr>
           <a:xfrm>
-            <a:off x="4562856" y="4133088"/>
+            <a:off x="4562856" y="4032504"/>
             <a:ext cx="1426464" cy="475488"/>
           </a:xfrm>
           <a:prstGeom prst="rect">
@@ -11684,12 +11684,12 @@
           <a:p>
             <a:pPr algn="l"/>
             <a:r>
-              <a:rPr sz="950" b="0">
+              <a:rPr sz="900" b="0">
                 <a:solidFill>
                   <a:srgbClr val="CBD5E1"/>
                 </a:solidFill>
               </a:rPr>
-              <a:t>Version history, diff, rollback</a:t>
+              <a:t>Invite, assign roles, deactivate users</a:t>
             </a:r>
           </a:p>
         </p:txBody>
@@ -11702,8 +11702,8 @@
         </p:nvSpPr>
         <p:spPr>
           <a:xfrm>
-            <a:off x="6245352" y="4069080"/>
-            <a:ext cx="2798064" cy="566928"/>
+            <a:off x="6245352" y="3977640"/>
+            <a:ext cx="2798064" cy="548640"/>
           </a:xfrm>
           <a:prstGeom prst="rect">
             <a:avLst/>
@@ -11745,7 +11745,7 @@
         </p:nvSpPr>
         <p:spPr>
           <a:xfrm>
-            <a:off x="6336792" y="4105656"/>
+            <a:off x="6336792" y="4005072"/>
             <a:ext cx="1188720" cy="475488"/>
           </a:xfrm>
           <a:prstGeom prst="rect">
@@ -11761,12 +11761,12 @@
           <a:p>
             <a:pPr algn="l"/>
             <a:r>
-              <a:rPr sz="1100" b="1">
+              <a:rPr sz="1050" b="1">
                 <a:solidFill>
                   <a:srgbClr val="606EF5"/>
                 </a:solidFill>
               </a:rPr>
-              <a:t>👤 Profile</a:t>
+              <a:t>📅 Agent Versions</a:t>
             </a:r>
           </a:p>
         </p:txBody>
@@ -11779,7 +11779,7 @@
         </p:nvSpPr>
         <p:spPr>
           <a:xfrm>
-            <a:off x="7525512" y="4133088"/>
+            <a:off x="7525512" y="4032504"/>
             <a:ext cx="1426464" cy="475488"/>
           </a:xfrm>
           <a:prstGeom prst="rect">
@@ -11795,12 +11795,12 @@
           <a:p>
             <a:pPr algn="l"/>
             <a:r>
-              <a:rPr sz="950" b="0">
+              <a:rPr sz="900" b="0">
                 <a:solidFill>
                   <a:srgbClr val="CBD5E1"/>
                 </a:solidFill>
               </a:rPr>
-              <a:t>User profile, password change</a:t>
+              <a:t>Version history, diff, rollback</a:t>
             </a:r>
           </a:p>
         </p:txBody>
@@ -11813,8 +11813,8 @@
         </p:nvSpPr>
         <p:spPr>
           <a:xfrm>
-            <a:off x="9208008" y="4069080"/>
-            <a:ext cx="2798064" cy="566928"/>
+            <a:off x="9208008" y="3977640"/>
+            <a:ext cx="2798064" cy="548640"/>
           </a:xfrm>
           <a:prstGeom prst="rect">
             <a:avLst/>
@@ -11856,7 +11856,7 @@
         </p:nvSpPr>
         <p:spPr>
           <a:xfrm>
-            <a:off x="9299448" y="4105656"/>
+            <a:off x="9299448" y="4005072"/>
             <a:ext cx="1188720" cy="475488"/>
           </a:xfrm>
           <a:prstGeom prst="rect">
@@ -11872,11 +11872,122 @@
           <a:p>
             <a:pPr algn="l"/>
             <a:r>
-              <a:rPr sz="1100" b="1">
+              <a:rPr sz="1050" b="1">
                 <a:solidFill>
                   <a:srgbClr val="606EF5"/>
                 </a:solidFill>
               </a:rPr>
+              <a:t>👤 Profile</a:t>
+            </a:r>
+          </a:p>
+        </p:txBody>
+      </p:sp>
+      <p:sp>
+        <p:nvSpPr>
+          <p:cNvPr id="76" name="TextBox 75"/>
+          <p:cNvSpPr txBox="1"/>
+          <p:nvPr/>
+        </p:nvSpPr>
+        <p:spPr>
+          <a:xfrm>
+            <a:off x="10488168" y="4032504"/>
+            <a:ext cx="1426464" cy="475488"/>
+          </a:xfrm>
+          <a:prstGeom prst="rect">
+            <a:avLst/>
+          </a:prstGeom>
+          <a:noFill/>
+        </p:spPr>
+        <p:txBody>
+          <a:bodyPr wrap="square">
+            <a:spAutoFit/>
+          </a:bodyPr>
+          <a:lstStyle/>
+          <a:p>
+            <a:pPr algn="l"/>
+            <a:r>
+              <a:rPr sz="900" b="0">
+                <a:solidFill>
+                  <a:srgbClr val="CBD5E1"/>
+                </a:solidFill>
+              </a:rPr>
+              <a:t>User profile, password change</a:t>
+            </a:r>
+          </a:p>
+        </p:txBody>
+      </p:sp>
+      <p:sp>
+        <p:nvSpPr>
+          <p:cNvPr id="77" name="Rectangle 76"/>
+          <p:cNvSpPr/>
+          <p:nvPr/>
+        </p:nvSpPr>
+        <p:spPr>
+          <a:xfrm>
+            <a:off x="320040" y="4581144"/>
+            <a:ext cx="2798064" cy="548640"/>
+          </a:xfrm>
+          <a:prstGeom prst="rect">
+            <a:avLst/>
+          </a:prstGeom>
+          <a:solidFill>
+            <a:srgbClr val="1E2A45"/>
+          </a:solidFill>
+          <a:ln>
+            <a:noFill/>
+          </a:ln>
+        </p:spPr>
+        <p:style>
+          <a:lnRef idx="1">
+            <a:schemeClr val="accent1"/>
+          </a:lnRef>
+          <a:fillRef idx="3">
+            <a:schemeClr val="accent1"/>
+          </a:fillRef>
+          <a:effectRef idx="2">
+            <a:schemeClr val="accent1"/>
+          </a:effectRef>
+          <a:fontRef idx="minor">
+            <a:schemeClr val="lt1"/>
+          </a:fontRef>
+        </p:style>
+        <p:txBody>
+          <a:bodyPr rtlCol="0" anchor="ctr"/>
+          <a:lstStyle/>
+          <a:p>
+            <a:pPr algn="ctr"/>
+          </a:p>
+        </p:txBody>
+      </p:sp>
+      <p:sp>
+        <p:nvSpPr>
+          <p:cNvPr id="78" name="TextBox 77"/>
+          <p:cNvSpPr txBox="1"/>
+          <p:nvPr/>
+        </p:nvSpPr>
+        <p:spPr>
+          <a:xfrm>
+            <a:off x="411480" y="4608576"/>
+            <a:ext cx="1188720" cy="475488"/>
+          </a:xfrm>
+          <a:prstGeom prst="rect">
+            <a:avLst/>
+          </a:prstGeom>
+          <a:noFill/>
+        </p:spPr>
+        <p:txBody>
+          <a:bodyPr wrap="square">
+            <a:spAutoFit/>
+          </a:bodyPr>
+          <a:lstStyle/>
+          <a:p>
+            <a:pPr algn="l"/>
+            <a:r>
+              <a:rPr sz="1050" b="1">
+                <a:solidFill>
+                  <a:srgbClr val="606EF5"/>
+                </a:solidFill>
+              </a:rPr>
               <a:t>⚙️ Settings</a:t>
             </a:r>
           </a:p>
@@ -11884,13 +11995,13 @@
       </p:sp>
       <p:sp>
         <p:nvSpPr>
-          <p:cNvPr id="76" name="TextBox 75"/>
-          <p:cNvSpPr txBox="1"/>
-          <p:nvPr/>
-        </p:nvSpPr>
-        <p:spPr>
-          <a:xfrm>
-            <a:off x="10488168" y="4133088"/>
+          <p:cNvPr id="79" name="TextBox 78"/>
+          <p:cNvSpPr txBox="1"/>
+          <p:nvPr/>
+        </p:nvSpPr>
+        <p:spPr>
+          <a:xfrm>
+            <a:off x="1600200" y="4636008"/>
             <a:ext cx="1426464" cy="475488"/>
           </a:xfrm>
           <a:prstGeom prst="rect">
@@ -11906,7 +12017,7 @@
           <a:p>
             <a:pPr algn="l"/>
             <a:r>
-              <a:rPr sz="950" b="0">
+              <a:rPr sz="900" b="0">
                 <a:solidFill>
                   <a:srgbClr val="CBD5E1"/>
                 </a:solidFill>
@@ -11918,7 +12029,7 @@
       </p:sp>
       <p:sp>
         <p:nvSpPr>
-          <p:cNvPr id="77" name="TextBox 76"/>
+          <p:cNvPr id="80" name="TextBox 79"/>
           <p:cNvSpPr txBox="1"/>
           <p:nvPr/>
         </p:nvSpPr>
@@ -20917,7 +21028,7 @@
                   <a:srgbClr val="606EF5"/>
                 </a:solidFill>
               </a:rPr>
-              <a:t>24 Frontend Pages</a:t>
+              <a:t>25 Frontend Pages</a:t>
             </a:r>
           </a:p>
         </p:txBody>

</xml_diff>